<commit_message>
Template QA pass: render-loop-safe CJK fonts across all zh decks
Swap PingFang SC / Heiti SC / Yuanti SC ea runs to Hiragino Sans GB in 7 zh
templates (chengdu keeps Songti serif by design), re-render all previews.
Fixes the handwriting-face substitution that corrupted the published viewer
previews for standup / solo / nl-job-market / kids. All 16 decks re-linted
clean. Profile.md font records updated.

Co-Authored-By: Claude Fable 5 <noreply@anthropic.com>
</commit_message>
<xml_diff>
--- a/templates/decks/zh/nvidia-overview/template.pptx
+++ b/templates/decks/zh/nvidia-overview/template.pptx
@@ -3223,8 +3223,8 @@
                   <a:srgbClr val="76B900"/>
                 </a:solidFill>
                 <a:latin typeface="Helvetica Neue"/>
-                <a:ea typeface="PingFang SC"/>
-                <a:cs typeface="PingFang SC"/>
+                <a:ea typeface="Hiragino Sans GB"/>
+                <a:cs typeface="Hiragino Sans GB"/>
               </a:rPr>
               <a:t>公司概览      2026</a:t>
             </a:r>
@@ -3338,8 +3338,8 @@
                   <a:srgbClr val="C8CDD4"/>
                 </a:solidFill>
                 <a:latin typeface="Helvetica Neue"/>
-                <a:ea typeface="PingFang SC"/>
-                <a:cs typeface="PingFang SC"/>
+                <a:ea typeface="Hiragino Sans GB"/>
+                <a:cs typeface="Hiragino Sans GB"/>
               </a:rPr>
               <a:t>驱动 AI、图形与 3D 的</a:t>
             </a:r>
@@ -3362,8 +3362,8 @@
                   <a:srgbClr val="C8CDD4"/>
                 </a:solidFill>
                 <a:latin typeface="Helvetica Neue"/>
-                <a:ea typeface="PingFang SC"/>
-                <a:cs typeface="PingFang SC"/>
+                <a:ea typeface="Hiragino Sans GB"/>
+                <a:cs typeface="Hiragino Sans GB"/>
               </a:rPr>
               <a:t>加速计算平台。</a:t>
             </a:r>
@@ -3508,8 +3508,8 @@
                   <a:srgbClr val="76B900"/>
                 </a:solidFill>
                 <a:latin typeface="Helvetica Neue"/>
-                <a:ea typeface="PingFang SC"/>
-                <a:cs typeface="PingFang SC"/>
+                <a:ea typeface="Hiragino Sans GB"/>
+                <a:cs typeface="Hiragino Sans GB"/>
               </a:rPr>
               <a:t>网络</a:t>
             </a:r>
@@ -3555,8 +3555,8 @@
                   <a:srgbClr val="FFFFFF"/>
                 </a:solidFill>
                 <a:latin typeface="Helvetica Neue"/>
-                <a:ea typeface="PingFang SC"/>
-                <a:cs typeface="PingFang SC"/>
+                <a:ea typeface="Hiragino Sans GB"/>
+                <a:cs typeface="Hiragino Sans GB"/>
               </a:rPr>
               <a:t>把上千颗 GPU 连成一台计算机</a:t>
             </a:r>
@@ -4630,8 +4630,8 @@
                   <a:srgbClr val="C8CDD4"/>
                 </a:solidFill>
                 <a:latin typeface="Helvetica Neue"/>
-                <a:ea typeface="PingFang SC"/>
-                <a:cs typeface="PingFang SC"/>
+                <a:ea typeface="Hiragino Sans GB"/>
+                <a:cs typeface="Hiragino Sans GB"/>
               </a:rPr>
               <a:t>一张 NVLink + InfiniBand / Spectrum-X 互联网络</a:t>
             </a:r>
@@ -4771,8 +4771,8 @@
                   <a:srgbClr val="76B900"/>
                 </a:solidFill>
                 <a:latin typeface="Helvetica Neue"/>
-                <a:ea typeface="PingFang SC"/>
-                <a:cs typeface="PingFang SC"/>
+                <a:ea typeface="Hiragino Sans GB"/>
+                <a:cs typeface="Hiragino Sans GB"/>
               </a:rPr>
               <a:t>$14.8B</a:t>
             </a:r>
@@ -4818,8 +4818,8 @@
                   <a:srgbClr val="FFFFFF"/>
                 </a:solidFill>
                 <a:latin typeface="Helvetica Neue"/>
-                <a:ea typeface="PingFang SC"/>
-                <a:cs typeface="PingFang SC"/>
+                <a:ea typeface="Hiragino Sans GB"/>
+                <a:cs typeface="Hiragino Sans GB"/>
               </a:rPr>
               <a:t>上季度网络业务</a:t>
             </a:r>
@@ -4865,8 +4865,8 @@
                   <a:srgbClr val="9AA3AE"/>
                 </a:solidFill>
                 <a:latin typeface="Helvetica Neue"/>
-                <a:ea typeface="PingFang SC"/>
-                <a:cs typeface="PingFang SC"/>
+                <a:ea typeface="Hiragino Sans GB"/>
+                <a:cs typeface="Hiragino Sans GB"/>
               </a:rPr>
               <a:t>同比 +199%；Spectrum-X 年化营收已过 $10B。</a:t>
             </a:r>
@@ -4912,8 +4912,8 @@
                   <a:srgbClr val="9AA3AE"/>
                 </a:solidFill>
                 <a:latin typeface="Helvetica Neue"/>
-                <a:ea typeface="PingFang SC"/>
-                <a:cs typeface="PingFang SC"/>
+                <a:ea typeface="Hiragino Sans GB"/>
+                <a:cs typeface="Hiragino Sans GB"/>
               </a:rPr>
               <a:t>2020 年收购 Mellanox，让 NVIDIA 成为全栈网络公司。</a:t>
             </a:r>
@@ -4983,8 +4983,8 @@
                   <a:srgbClr val="9AA3AE"/>
                 </a:solidFill>
                 <a:latin typeface="Helvetica Neue"/>
-                <a:ea typeface="PingFang SC"/>
-                <a:cs typeface="PingFang SC"/>
+                <a:ea typeface="Hiragino Sans GB"/>
+                <a:cs typeface="Hiragino Sans GB"/>
               </a:rPr>
               <a:t>10 / 16</a:t>
             </a:r>
@@ -5129,8 +5129,8 @@
                   <a:srgbClr val="76B900"/>
                 </a:solidFill>
                 <a:latin typeface="Helvetica Neue"/>
-                <a:ea typeface="PingFang SC"/>
-                <a:cs typeface="PingFang SC"/>
+                <a:ea typeface="Hiragino Sans GB"/>
+                <a:cs typeface="Hiragino Sans GB"/>
               </a:rPr>
               <a:t>游戏 · 一切的起点</a:t>
             </a:r>
@@ -5176,8 +5176,8 @@
                   <a:srgbClr val="FFFFFF"/>
                 </a:solidFill>
                 <a:latin typeface="Helvetica Neue"/>
-                <a:ea typeface="PingFang SC"/>
-                <a:cs typeface="PingFang SC"/>
+                <a:ea typeface="Hiragino Sans GB"/>
+                <a:cs typeface="Hiragino Sans GB"/>
               </a:rPr>
               <a:t>GeForce RTX，实时、AI 加速的图形</a:t>
             </a:r>
@@ -5386,8 +5386,8 @@
                   <a:srgbClr val="FFFFFF"/>
                 </a:solidFill>
                 <a:latin typeface="Helvetica Neue"/>
-                <a:ea typeface="PingFang SC"/>
-                <a:cs typeface="PingFang SC"/>
+                <a:ea typeface="Hiragino Sans GB"/>
+                <a:cs typeface="Hiragino Sans GB"/>
               </a:rPr>
               <a:t>光线追踪</a:t>
             </a:r>
@@ -5433,8 +5433,8 @@
                   <a:srgbClr val="9AA3AE"/>
                 </a:solidFill>
                 <a:latin typeface="Helvetica Neue"/>
-                <a:ea typeface="PingFang SC"/>
-                <a:cs typeface="PingFang SC"/>
+                <a:ea typeface="Hiragino Sans GB"/>
+                <a:cs typeface="Hiragino Sans GB"/>
               </a:rPr>
               <a:t>实时呈现电影级、物理精确的光影。</a:t>
             </a:r>
@@ -5599,8 +5599,8 @@
                   <a:srgbClr val="FFFFFF"/>
                 </a:solidFill>
                 <a:latin typeface="Helvetica Neue"/>
-                <a:ea typeface="PingFang SC"/>
-                <a:cs typeface="PingFang SC"/>
+                <a:ea typeface="Hiragino Sans GB"/>
+                <a:cs typeface="Hiragino Sans GB"/>
               </a:rPr>
               <a:t>DLSS AI 渲染</a:t>
             </a:r>
@@ -5646,8 +5646,8 @@
                   <a:srgbClr val="9AA3AE"/>
                 </a:solidFill>
                 <a:latin typeface="Helvetica Neue"/>
-                <a:ea typeface="PingFang SC"/>
-                <a:cs typeface="PingFang SC"/>
+                <a:ea typeface="Hiragino Sans GB"/>
+                <a:cs typeface="Hiragino Sans GB"/>
               </a:rPr>
               <a:t>神经渲染让帧率成倍提升。</a:t>
             </a:r>
@@ -5812,8 +5812,8 @@
                   <a:srgbClr val="FFFFFF"/>
                 </a:solidFill>
                 <a:latin typeface="Helvetica Neue"/>
-                <a:ea typeface="PingFang SC"/>
-                <a:cs typeface="PingFang SC"/>
+                <a:ea typeface="Hiragino Sans GB"/>
+                <a:cs typeface="Hiragino Sans GB"/>
               </a:rPr>
               <a:t>同一套架构</a:t>
             </a:r>
@@ -5859,8 +5859,8 @@
                   <a:srgbClr val="9AA3AE"/>
                 </a:solidFill>
                 <a:latin typeface="Helvetica Neue"/>
-                <a:ea typeface="PingFang SC"/>
-                <a:cs typeface="PingFang SC"/>
+                <a:ea typeface="Hiragino Sans GB"/>
+                <a:cs typeface="Hiragino Sans GB"/>
               </a:rPr>
               <a:t>与数据中心同源的 Blackwell 架构。</a:t>
             </a:r>
@@ -6025,8 +6025,8 @@
                   <a:srgbClr val="FFFFFF"/>
                 </a:solidFill>
                 <a:latin typeface="Helvetica Neue"/>
-                <a:ea typeface="PingFang SC"/>
-                <a:cs typeface="PingFang SC"/>
+                <a:ea typeface="Hiragino Sans GB"/>
+                <a:cs typeface="Hiragino Sans GB"/>
               </a:rPr>
               <a:t>GeForce NOW</a:t>
             </a:r>
@@ -6072,8 +6072,8 @@
                   <a:srgbClr val="9AA3AE"/>
                 </a:solidFill>
                 <a:latin typeface="Helvetica Neue"/>
-                <a:ea typeface="PingFang SC"/>
-                <a:cs typeface="PingFang SC"/>
+                <a:ea typeface="Hiragino Sans GB"/>
+                <a:cs typeface="Hiragino Sans GB"/>
               </a:rPr>
               <a:t>把整台主机从云端串流到任意设备。</a:t>
             </a:r>
@@ -6143,8 +6143,8 @@
                   <a:srgbClr val="9AA3AE"/>
                 </a:solidFill>
                 <a:latin typeface="Helvetica Neue"/>
-                <a:ea typeface="PingFang SC"/>
-                <a:cs typeface="PingFang SC"/>
+                <a:ea typeface="Hiragino Sans GB"/>
+                <a:cs typeface="Hiragino Sans GB"/>
               </a:rPr>
               <a:t>11 / 16</a:t>
             </a:r>
@@ -6289,8 +6289,8 @@
                   <a:srgbClr val="76B900"/>
                 </a:solidFill>
                 <a:latin typeface="Helvetica Neue"/>
-                <a:ea typeface="PingFang SC"/>
-                <a:cs typeface="PingFang SC"/>
+                <a:ea typeface="Hiragino Sans GB"/>
+                <a:cs typeface="Hiragino Sans GB"/>
               </a:rPr>
               <a:t>仿真 · 数字孪生</a:t>
             </a:r>
@@ -6336,8 +6336,8 @@
                   <a:srgbClr val="FFFFFF"/>
                 </a:solidFill>
                 <a:latin typeface="Helvetica Neue"/>
-                <a:ea typeface="PingFang SC"/>
-                <a:cs typeface="PingFang SC"/>
+                <a:ea typeface="Hiragino Sans GB"/>
+                <a:cs typeface="Hiragino Sans GB"/>
               </a:rPr>
               <a:t>Omniverse，物理 AI 的操作系统</a:t>
             </a:r>
@@ -6427,8 +6427,8 @@
                   <a:srgbClr val="C8CDD4"/>
                 </a:solidFill>
                 <a:latin typeface="Helvetica Neue"/>
-                <a:ea typeface="PingFang SC"/>
-                <a:cs typeface="PingFang SC"/>
+                <a:ea typeface="Hiragino Sans GB"/>
+                <a:cs typeface="Hiragino Sans GB"/>
               </a:rPr>
               <a:t>在 OpenUSD 上构建物理精确的 3D 数字孪生，先在仿真里测试真实世界。</a:t>
             </a:r>
@@ -6568,8 +6568,8 @@
                   <a:srgbClr val="76B900"/>
                 </a:solidFill>
                 <a:latin typeface="Helvetica Neue"/>
-                <a:ea typeface="PingFang SC"/>
-                <a:cs typeface="PingFang SC"/>
+                <a:ea typeface="Hiragino Sans GB"/>
+                <a:cs typeface="Hiragino Sans GB"/>
               </a:rPr>
               <a:t>约 30%</a:t>
             </a:r>
@@ -6615,8 +6615,8 @@
                   <a:srgbClr val="C8CDD4"/>
                 </a:solidFill>
                 <a:latin typeface="Helvetica Neue"/>
-                <a:ea typeface="PingFang SC"/>
-                <a:cs typeface="PingFang SC"/>
+                <a:ea typeface="Hiragino Sans GB"/>
+                <a:cs typeface="Hiragino Sans GB"/>
               </a:rPr>
               <a:t>更低的工厂规划成本，宝马已在虚拟环境中验证了整座工厂。</a:t>
             </a:r>
@@ -6756,8 +6756,8 @@
                   <a:srgbClr val="76B900"/>
                 </a:solidFill>
                 <a:latin typeface="Helvetica Neue"/>
-                <a:ea typeface="PingFang SC"/>
-                <a:cs typeface="PingFang SC"/>
+                <a:ea typeface="Hiragino Sans GB"/>
+                <a:cs typeface="Hiragino Sans GB"/>
               </a:rPr>
               <a:t>约 1,000×</a:t>
             </a:r>
@@ -6803,8 +6803,8 @@
                   <a:srgbClr val="C8CDD4"/>
                 </a:solidFill>
                 <a:latin typeface="Helvetica Neue"/>
-                <a:ea typeface="PingFang SC"/>
-                <a:cs typeface="PingFang SC"/>
+                <a:ea typeface="Hiragino Sans GB"/>
+                <a:cs typeface="Hiragino Sans GB"/>
               </a:rPr>
               <a:t>用 Earth-2 让预测提速千倍，能效还高约 3,000 倍。</a:t>
             </a:r>
@@ -6898,8 +6898,8 @@
                   <a:srgbClr val="C8CDD4"/>
                 </a:solidFill>
                 <a:latin typeface="Helvetica Neue"/>
-                <a:ea typeface="PingFang SC"/>
-                <a:cs typeface="PingFang SC"/>
+                <a:ea typeface="Hiragino Sans GB"/>
+                <a:cs typeface="Hiragino Sans GB"/>
               </a:rPr>
               <a:t>BMW</a:t>
             </a:r>
@@ -6993,8 +6993,8 @@
                   <a:srgbClr val="C8CDD4"/>
                 </a:solidFill>
                 <a:latin typeface="Helvetica Neue"/>
-                <a:ea typeface="PingFang SC"/>
-                <a:cs typeface="PingFang SC"/>
+                <a:ea typeface="Hiragino Sans GB"/>
+                <a:cs typeface="Hiragino Sans GB"/>
               </a:rPr>
               <a:t>Mercedes-Benz</a:t>
             </a:r>
@@ -7088,8 +7088,8 @@
                   <a:srgbClr val="C8CDD4"/>
                 </a:solidFill>
                 <a:latin typeface="Helvetica Neue"/>
-                <a:ea typeface="PingFang SC"/>
-                <a:cs typeface="PingFang SC"/>
+                <a:ea typeface="Hiragino Sans GB"/>
+                <a:cs typeface="Hiragino Sans GB"/>
               </a:rPr>
               <a:t>Siemens</a:t>
             </a:r>
@@ -7183,8 +7183,8 @@
                   <a:srgbClr val="C8CDD4"/>
                 </a:solidFill>
                 <a:latin typeface="Helvetica Neue"/>
-                <a:ea typeface="PingFang SC"/>
-                <a:cs typeface="PingFang SC"/>
+                <a:ea typeface="Hiragino Sans GB"/>
+                <a:cs typeface="Hiragino Sans GB"/>
               </a:rPr>
               <a:t>Ansys</a:t>
             </a:r>
@@ -7278,8 +7278,8 @@
                   <a:srgbClr val="C8CDD4"/>
                 </a:solidFill>
                 <a:latin typeface="Helvetica Neue"/>
-                <a:ea typeface="PingFang SC"/>
-                <a:cs typeface="PingFang SC"/>
+                <a:ea typeface="Hiragino Sans GB"/>
+                <a:cs typeface="Hiragino Sans GB"/>
               </a:rPr>
               <a:t>Foxconn</a:t>
             </a:r>
@@ -7349,8 +7349,8 @@
                   <a:srgbClr val="9AA3AE"/>
                 </a:solidFill>
                 <a:latin typeface="Helvetica Neue"/>
-                <a:ea typeface="PingFang SC"/>
-                <a:cs typeface="PingFang SC"/>
+                <a:ea typeface="Hiragino Sans GB"/>
+                <a:cs typeface="Hiragino Sans GB"/>
               </a:rPr>
               <a:t>12 / 16</a:t>
             </a:r>
@@ -7495,8 +7495,8 @@
                   <a:srgbClr val="76B900"/>
                 </a:solidFill>
                 <a:latin typeface="Helvetica Neue"/>
-                <a:ea typeface="PingFang SC"/>
-                <a:cs typeface="PingFang SC"/>
+                <a:ea typeface="Hiragino Sans GB"/>
+                <a:cs typeface="Hiragino Sans GB"/>
               </a:rPr>
               <a:t>物理 AI</a:t>
             </a:r>
@@ -7542,8 +7542,8 @@
                   <a:srgbClr val="FFFFFF"/>
                 </a:solidFill>
                 <a:latin typeface="Helvetica Neue"/>
-                <a:ea typeface="PingFang SC"/>
-                <a:cs typeface="PingFang SC"/>
+                <a:ea typeface="Hiragino Sans GB"/>
+                <a:cs typeface="Hiragino Sans GB"/>
               </a:rPr>
               <a:t>从汽车到机器人</a:t>
             </a:r>
@@ -7752,8 +7752,8 @@
                   <a:srgbClr val="FFFFFF"/>
                 </a:solidFill>
                 <a:latin typeface="Helvetica Neue"/>
-                <a:ea typeface="PingFang SC"/>
-                <a:cs typeface="PingFang SC"/>
+                <a:ea typeface="Hiragino Sans GB"/>
+                <a:cs typeface="Hiragino Sans GB"/>
               </a:rPr>
               <a:t>自动驾驶汽车</a:t>
             </a:r>
@@ -7799,8 +7799,8 @@
                   <a:srgbClr val="C8CDD4"/>
                 </a:solidFill>
                 <a:latin typeface="Helvetica Neue"/>
-                <a:ea typeface="PingFang SC"/>
-                <a:cs typeface="PingFang SC"/>
+                <a:ea typeface="Hiragino Sans GB"/>
+                <a:cs typeface="Hiragino Sans GB"/>
               </a:rPr>
               <a:t>DRIVE AGX Thor 加 Hyperion 驱动 BYD、Mercedes-Benz、Lucid 和 JLR，还与 Uber 合力推进全球 robotaxi。</a:t>
             </a:r>
@@ -7890,8 +7890,8 @@
                   <a:srgbClr val="9AA3AE"/>
                 </a:solidFill>
                 <a:latin typeface="Helvetica Neue"/>
-                <a:ea typeface="PingFang SC"/>
-                <a:cs typeface="PingFang SC"/>
+                <a:ea typeface="Hiragino Sans GB"/>
+                <a:cs typeface="Hiragino Sans GB"/>
               </a:rPr>
               <a:t>BYD  ·  Mercedes-Benz  ·  Lucid  ·  Uber</a:t>
             </a:r>
@@ -8056,8 +8056,8 @@
                   <a:srgbClr val="FFFFFF"/>
                 </a:solidFill>
                 <a:latin typeface="Helvetica Neue"/>
-                <a:ea typeface="PingFang SC"/>
-                <a:cs typeface="PingFang SC"/>
+                <a:ea typeface="Hiragino Sans GB"/>
+                <a:cs typeface="Hiragino Sans GB"/>
               </a:rPr>
               <a:t>机器人</a:t>
             </a:r>
@@ -8103,8 +8103,8 @@
                   <a:srgbClr val="C8CDD4"/>
                 </a:solidFill>
                 <a:latin typeface="Helvetica Neue"/>
-                <a:ea typeface="PingFang SC"/>
-                <a:cs typeface="PingFang SC"/>
+                <a:ea typeface="Hiragino Sans GB"/>
+                <a:cs typeface="Hiragino Sans GB"/>
               </a:rPr>
               <a:t>Jetson Thor 加 Isaac 加开放的 GR00T 人形模型，驱动 Boston Dynamics、Figure 和工厂机器人。</a:t>
             </a:r>
@@ -8194,8 +8194,8 @@
                   <a:srgbClr val="9AA3AE"/>
                 </a:solidFill>
                 <a:latin typeface="Helvetica Neue"/>
-                <a:ea typeface="PingFang SC"/>
-                <a:cs typeface="PingFang SC"/>
+                <a:ea typeface="Hiragino Sans GB"/>
+                <a:cs typeface="Hiragino Sans GB"/>
               </a:rPr>
               <a:t>Boston Dynamics  ·  Figure  ·  ABB  ·  FANUC</a:t>
             </a:r>
@@ -8265,8 +8265,8 @@
                   <a:srgbClr val="9AA3AE"/>
                 </a:solidFill>
                 <a:latin typeface="Helvetica Neue"/>
-                <a:ea typeface="PingFang SC"/>
-                <a:cs typeface="PingFang SC"/>
+                <a:ea typeface="Hiragino Sans GB"/>
+                <a:cs typeface="Hiragino Sans GB"/>
               </a:rPr>
               <a:t>13 / 16</a:t>
             </a:r>
@@ -8411,8 +8411,8 @@
                   <a:srgbClr val="76B900"/>
                 </a:solidFill>
                 <a:latin typeface="Helvetica Neue"/>
-                <a:ea typeface="PingFang SC"/>
-                <a:cs typeface="PingFang SC"/>
+                <a:ea typeface="Hiragino Sans GB"/>
+                <a:cs typeface="Hiragino Sans GB"/>
               </a:rPr>
               <a:t>价值所在</a:t>
             </a:r>
@@ -8458,8 +8458,8 @@
                   <a:srgbClr val="FFFFFF"/>
                 </a:solidFill>
                 <a:latin typeface="Helvetica Neue"/>
-                <a:ea typeface="PingFang SC"/>
-                <a:cs typeface="PingFang SC"/>
+                <a:ea typeface="Hiragino Sans GB"/>
+                <a:cs typeface="Hiragino Sans GB"/>
               </a:rPr>
               <a:t>客户为什么选 NVIDIA</a:t>
             </a:r>
@@ -8667,8 +8667,8 @@
                   <a:srgbClr val="FFFFFF"/>
                 </a:solidFill>
                 <a:latin typeface="Helvetica Neue"/>
-                <a:ea typeface="PingFang SC"/>
-                <a:cs typeface="PingFang SC"/>
+                <a:ea typeface="Hiragino Sans GB"/>
+                <a:cs typeface="Hiragino Sans GB"/>
               </a:rPr>
               <a:t>一个全栈平台</a:t>
             </a:r>
@@ -8714,8 +8714,8 @@
                   <a:srgbClr val="C8CDD4"/>
                 </a:solidFill>
                 <a:latin typeface="Helvetica Neue"/>
-                <a:ea typeface="PingFang SC"/>
-                <a:cs typeface="PingFang SC"/>
+                <a:ea typeface="Hiragino Sans GB"/>
+                <a:cs typeface="Hiragino Sans GB"/>
               </a:rPr>
               <a:t>芯片、系统、网络与软件，经过验证能协同运转。</a:t>
             </a:r>
@@ -8879,8 +8879,8 @@
                   <a:srgbClr val="FFFFFF"/>
                 </a:solidFill>
                 <a:latin typeface="Helvetica Neue"/>
-                <a:ea typeface="PingFang SC"/>
-                <a:cs typeface="PingFang SC"/>
+                <a:ea typeface="Hiragino Sans GB"/>
+                <a:cs typeface="Hiragino Sans GB"/>
               </a:rPr>
               <a:t>处处可扩展</a:t>
             </a:r>
@@ -8926,8 +8926,8 @@
                   <a:srgbClr val="C8CDD4"/>
                 </a:solidFill>
                 <a:latin typeface="Helvetica Neue"/>
-                <a:ea typeface="PingFang SC"/>
-                <a:cs typeface="PingFang SC"/>
+                <a:ea typeface="Hiragino Sans GB"/>
+                <a:cs typeface="Hiragino Sans GB"/>
               </a:rPr>
               <a:t>从一台游戏笔记本，到一座机架级 AI 工厂。</a:t>
             </a:r>
@@ -9091,8 +9091,8 @@
                   <a:srgbClr val="FFFFFF"/>
                 </a:solidFill>
                 <a:latin typeface="Helvetica Neue"/>
-                <a:ea typeface="PingFang SC"/>
-                <a:cs typeface="PingFang SC"/>
+                <a:ea typeface="Hiragino Sans GB"/>
+                <a:cs typeface="Hiragino Sans GB"/>
               </a:rPr>
               <a:t>最大的生态</a:t>
             </a:r>
@@ -9138,8 +9138,8 @@
                   <a:srgbClr val="C8CDD4"/>
                 </a:solidFill>
                 <a:latin typeface="Helvetica Neue"/>
-                <a:ea typeface="PingFang SC"/>
-                <a:cs typeface="PingFang SC"/>
+                <a:ea typeface="Hiragino Sans GB"/>
+                <a:cs typeface="Hiragino Sans GB"/>
               </a:rPr>
               <a:t>约 600 万开发者，以及业界最深的软件栈。</a:t>
             </a:r>
@@ -9303,8 +9303,8 @@
                   <a:srgbClr val="FFFFFF"/>
                 </a:solidFill>
                 <a:latin typeface="Helvetica Neue"/>
-                <a:ea typeface="PingFang SC"/>
-                <a:cs typeface="PingFang SC"/>
+                <a:ea typeface="Hiragino Sans GB"/>
+                <a:cs typeface="Hiragino Sans GB"/>
               </a:rPr>
               <a:t>规模化验证</a:t>
             </a:r>
@@ -9350,8 +9350,8 @@
                   <a:srgbClr val="C8CDD4"/>
                 </a:solidFill>
                 <a:latin typeface="Helvetica Neue"/>
-                <a:ea typeface="PingFang SC"/>
-                <a:cs typeface="PingFang SC"/>
+                <a:ea typeface="Hiragino Sans GB"/>
+                <a:cs typeface="Hiragino Sans GB"/>
               </a:rPr>
               <a:t>全世界领先的 AI，已经建在这个平台上。</a:t>
             </a:r>
@@ -9421,8 +9421,8 @@
                   <a:srgbClr val="9AA3AE"/>
                 </a:solidFill>
                 <a:latin typeface="Helvetica Neue"/>
-                <a:ea typeface="PingFang SC"/>
-                <a:cs typeface="PingFang SC"/>
+                <a:ea typeface="Hiragino Sans GB"/>
+                <a:cs typeface="Hiragino Sans GB"/>
               </a:rPr>
               <a:t>14 / 16</a:t>
             </a:r>
@@ -9567,8 +9567,8 @@
                   <a:srgbClr val="76B900"/>
                 </a:solidFill>
                 <a:latin typeface="Helvetica Neue"/>
-                <a:ea typeface="PingFang SC"/>
-                <a:cs typeface="PingFang SC"/>
+                <a:ea typeface="Hiragino Sans GB"/>
+                <a:cs typeface="Hiragino Sans GB"/>
               </a:rPr>
               <a:t>增长曲线</a:t>
             </a:r>
@@ -9614,8 +9614,8 @@
                   <a:srgbClr val="FFFFFF"/>
                 </a:solidFill>
                 <a:latin typeface="Helvetica Neue"/>
-                <a:ea typeface="PingFang SC"/>
-                <a:cs typeface="PingFang SC"/>
+                <a:ea typeface="Hiragino Sans GB"/>
+                <a:cs typeface="Hiragino Sans GB"/>
               </a:rPr>
               <a:t>增长之上再增长</a:t>
             </a:r>
@@ -9705,8 +9705,8 @@
                   <a:srgbClr val="9AA3AE"/>
                 </a:solidFill>
                 <a:latin typeface="Helvetica Neue"/>
-                <a:ea typeface="PingFang SC"/>
-                <a:cs typeface="PingFang SC"/>
+                <a:ea typeface="Hiragino Sans GB"/>
+                <a:cs typeface="Hiragino Sans GB"/>
               </a:rPr>
               <a:t>按财年（每年 1 月底结束）划分的营收，且截至 2026 年已锁定 ≥ $500B 的 Blackwell 加 Rubin 订单。</a:t>
             </a:r>
@@ -9801,8 +9801,8 @@
                   <a:srgbClr val="FFFFFF"/>
                 </a:solidFill>
                 <a:latin typeface="Helvetica Neue"/>
-                <a:ea typeface="PingFang SC"/>
-                <a:cs typeface="PingFang SC"/>
+                <a:ea typeface="Hiragino Sans GB"/>
+                <a:cs typeface="Hiragino Sans GB"/>
               </a:rPr>
               <a:t>$60.9B</a:t>
             </a:r>
@@ -9848,8 +9848,8 @@
                   <a:srgbClr val="9AA3AE"/>
                 </a:solidFill>
                 <a:latin typeface="Helvetica Neue"/>
-                <a:ea typeface="PingFang SC"/>
-                <a:cs typeface="PingFang SC"/>
+                <a:ea typeface="Hiragino Sans GB"/>
+                <a:cs typeface="Hiragino Sans GB"/>
               </a:rPr>
               <a:t>2024 财年</a:t>
             </a:r>
@@ -9944,8 +9944,8 @@
                   <a:srgbClr val="FFFFFF"/>
                 </a:solidFill>
                 <a:latin typeface="Helvetica Neue"/>
-                <a:ea typeface="PingFang SC"/>
-                <a:cs typeface="PingFang SC"/>
+                <a:ea typeface="Hiragino Sans GB"/>
+                <a:cs typeface="Hiragino Sans GB"/>
               </a:rPr>
               <a:t>$130.5B</a:t>
             </a:r>
@@ -9991,8 +9991,8 @@
                   <a:srgbClr val="9AA3AE"/>
                 </a:solidFill>
                 <a:latin typeface="Helvetica Neue"/>
-                <a:ea typeface="PingFang SC"/>
-                <a:cs typeface="PingFang SC"/>
+                <a:ea typeface="Hiragino Sans GB"/>
+                <a:cs typeface="Hiragino Sans GB"/>
               </a:rPr>
               <a:t>2025 财年</a:t>
             </a:r>
@@ -10087,8 +10087,8 @@
                   <a:srgbClr val="76B900"/>
                 </a:solidFill>
                 <a:latin typeface="Helvetica Neue"/>
-                <a:ea typeface="PingFang SC"/>
-                <a:cs typeface="PingFang SC"/>
+                <a:ea typeface="Hiragino Sans GB"/>
+                <a:cs typeface="Hiragino Sans GB"/>
               </a:rPr>
               <a:t>$215.9B</a:t>
             </a:r>
@@ -10134,8 +10134,8 @@
                   <a:srgbClr val="9AA3AE"/>
                 </a:solidFill>
                 <a:latin typeface="Helvetica Neue"/>
-                <a:ea typeface="PingFang SC"/>
-                <a:cs typeface="PingFang SC"/>
+                <a:ea typeface="Hiragino Sans GB"/>
+                <a:cs typeface="Hiragino Sans GB"/>
               </a:rPr>
               <a:t>2026 财年</a:t>
             </a:r>
@@ -10249,8 +10249,8 @@
                   <a:srgbClr val="9AA3AE"/>
                 </a:solidFill>
                 <a:latin typeface="Helvetica Neue"/>
-                <a:ea typeface="PingFang SC"/>
-                <a:cs typeface="PingFang SC"/>
+                <a:ea typeface="Hiragino Sans GB"/>
+                <a:cs typeface="Hiragino Sans GB"/>
               </a:rPr>
               <a:t>15 / 16</a:t>
             </a:r>
@@ -10395,8 +10395,8 @@
                   <a:srgbClr val="76B900"/>
                 </a:solidFill>
                 <a:latin typeface="Helvetica Neue"/>
-                <a:ea typeface="PingFang SC"/>
-                <a:cs typeface="PingFang SC"/>
+                <a:ea typeface="Hiragino Sans GB"/>
+                <a:cs typeface="Hiragino Sans GB"/>
               </a:rPr>
               <a:t>开始上手</a:t>
             </a:r>
@@ -10442,8 +10442,8 @@
                   <a:srgbClr val="FFFFFF"/>
                 </a:solidFill>
                 <a:latin typeface="Helvetica Neue"/>
-                <a:ea typeface="PingFang SC"/>
-                <a:cs typeface="PingFang SC"/>
+                <a:ea typeface="Hiragino Sans GB"/>
+                <a:cs typeface="Hiragino Sans GB"/>
               </a:rPr>
               <a:t>探索这个平台</a:t>
             </a:r>
@@ -10557,8 +10557,8 @@
                   <a:srgbClr val="FFFFFF"/>
                 </a:solidFill>
                 <a:latin typeface="Helvetica Neue"/>
-                <a:ea typeface="PingFang SC"/>
-                <a:cs typeface="PingFang SC"/>
+                <a:ea typeface="Hiragino Sans GB"/>
+                <a:cs typeface="Hiragino Sans GB"/>
               </a:rPr>
               <a:t>developer.nvidia.com</a:t>
             </a:r>
@@ -10604,8 +10604,8 @@
                   <a:srgbClr val="9AA3AE"/>
                 </a:solidFill>
                 <a:latin typeface="Helvetica Neue"/>
-                <a:ea typeface="PingFang SC"/>
-                <a:cs typeface="PingFang SC"/>
+                <a:ea typeface="Hiragino Sans GB"/>
+                <a:cs typeface="Hiragino Sans GB"/>
               </a:rPr>
               <a:t>CUDA、SDK 与开发者生态</a:t>
             </a:r>
@@ -10675,8 +10675,8 @@
                   <a:srgbClr val="FFFFFF"/>
                 </a:solidFill>
                 <a:latin typeface="Helvetica Neue"/>
-                <a:ea typeface="PingFang SC"/>
-                <a:cs typeface="PingFang SC"/>
+                <a:ea typeface="Hiragino Sans GB"/>
+                <a:cs typeface="Hiragino Sans GB"/>
               </a:rPr>
               <a:t>NVIDIA AI Enterprise</a:t>
             </a:r>
@@ -10722,8 +10722,8 @@
                   <a:srgbClr val="9AA3AE"/>
                 </a:solidFill>
                 <a:latin typeface="Helvetica Neue"/>
-                <a:ea typeface="PingFang SC"/>
-                <a:cs typeface="PingFang SC"/>
+                <a:ea typeface="Hiragino Sans GB"/>
+                <a:cs typeface="Hiragino Sans GB"/>
               </a:rPr>
               <a:t>面向任何企业、可直接投产的 AI</a:t>
             </a:r>
@@ -10793,8 +10793,8 @@
                   <a:srgbClr val="FFFFFF"/>
                 </a:solidFill>
                 <a:latin typeface="Helvetica Neue"/>
-                <a:ea typeface="PingFang SC"/>
-                <a:cs typeface="PingFang SC"/>
+                <a:ea typeface="Hiragino Sans GB"/>
+                <a:cs typeface="Hiragino Sans GB"/>
               </a:rPr>
               <a:t>Omniverse · GeForce · DRIVE</a:t>
             </a:r>
@@ -10840,8 +10840,8 @@
                   <a:srgbClr val="9AA3AE"/>
                 </a:solidFill>
                 <a:latin typeface="Helvetica Neue"/>
-                <a:ea typeface="PingFang SC"/>
-                <a:cs typeface="PingFang SC"/>
+                <a:ea typeface="Hiragino Sans GB"/>
+                <a:cs typeface="Hiragino Sans GB"/>
               </a:rPr>
               <a:t>仿真、游戏与自动驾驶</a:t>
             </a:r>
@@ -10911,8 +10911,8 @@
                   <a:srgbClr val="76B900"/>
                 </a:solidFill>
                 <a:latin typeface="Helvetica Neue"/>
-                <a:ea typeface="PingFang SC"/>
-                <a:cs typeface="PingFang SC"/>
+                <a:ea typeface="Hiragino Sans GB"/>
+                <a:cs typeface="Hiragino Sans GB"/>
               </a:rPr>
               <a:t>AI 时代的引擎。</a:t>
             </a:r>
@@ -11057,8 +11057,8 @@
                   <a:srgbClr val="76B900"/>
                 </a:solidFill>
                 <a:latin typeface="Helvetica Neue"/>
-                <a:ea typeface="PingFang SC"/>
-                <a:cs typeface="PingFang SC"/>
+                <a:ea typeface="Hiragino Sans GB"/>
+                <a:cs typeface="Hiragino Sans GB"/>
               </a:rPr>
               <a:t>我们是谁</a:t>
             </a:r>
@@ -11104,8 +11104,8 @@
                   <a:srgbClr val="FFFFFF"/>
                 </a:solidFill>
                 <a:latin typeface="Helvetica Neue"/>
-                <a:ea typeface="PingFang SC"/>
-                <a:cs typeface="PingFang SC"/>
+                <a:ea typeface="Hiragino Sans GB"/>
+                <a:cs typeface="Hiragino Sans GB"/>
               </a:rPr>
               <a:t>NVIDIA 打造芯片、</a:t>
             </a:r>
@@ -11128,8 +11128,8 @@
                   <a:srgbClr val="FFFFFF"/>
                 </a:solidFill>
                 <a:latin typeface="Helvetica Neue"/>
-                <a:ea typeface="PingFang SC"/>
-                <a:cs typeface="PingFang SC"/>
+                <a:ea typeface="Hiragino Sans GB"/>
+                <a:cs typeface="Hiragino Sans GB"/>
               </a:rPr>
               <a:t>系统、网络与</a:t>
             </a:r>
@@ -11152,8 +11152,8 @@
                   <a:srgbClr val="FFFFFF"/>
                 </a:solidFill>
                 <a:latin typeface="Helvetica Neue"/>
-                <a:ea typeface="PingFang SC"/>
-                <a:cs typeface="PingFang SC"/>
+                <a:ea typeface="Hiragino Sans GB"/>
+                <a:cs typeface="Hiragino Sans GB"/>
               </a:rPr>
               <a:t>软件，全世界的 AI</a:t>
             </a:r>
@@ -11176,8 +11176,8 @@
                   <a:srgbClr val="FFFFFF"/>
                 </a:solidFill>
                 <a:latin typeface="Helvetica Neue"/>
-                <a:ea typeface="PingFang SC"/>
-                <a:cs typeface="PingFang SC"/>
+                <a:ea typeface="Hiragino Sans GB"/>
+                <a:cs typeface="Hiragino Sans GB"/>
               </a:rPr>
               <a:t>都跑在上面。</a:t>
             </a:r>
@@ -11187,8 +11187,8 @@
                   <a:srgbClr val="76B900"/>
                 </a:solidFill>
                 <a:latin typeface="Helvetica Neue"/>
-                <a:ea typeface="PingFang SC"/>
-                <a:cs typeface="PingFang SC"/>
+                <a:ea typeface="Hiragino Sans GB"/>
+                <a:cs typeface="Hiragino Sans GB"/>
               </a:rPr>
               <a:t/>
             </a:r>
@@ -11198,8 +11198,8 @@
                   <a:srgbClr val="FFFFFF"/>
                 </a:solidFill>
                 <a:latin typeface="Helvetica Neue"/>
-                <a:ea typeface="PingFang SC"/>
-                <a:cs typeface="PingFang SC"/>
+                <a:ea typeface="Hiragino Sans GB"/>
+                <a:cs typeface="Hiragino Sans GB"/>
               </a:rPr>
               <a:t/>
             </a:r>
@@ -11289,8 +11289,8 @@
                   <a:srgbClr val="C8CDD4"/>
                 </a:solidFill>
                 <a:latin typeface="Helvetica Neue"/>
-                <a:ea typeface="PingFang SC"/>
-                <a:cs typeface="PingFang SC"/>
+                <a:ea typeface="Hiragino Sans GB"/>
+                <a:cs typeface="Hiragino Sans GB"/>
               </a:rPr>
               <a:t>创立于 1993 年 · 黄仁勋掌舵 · AI 时代的全栈平台。</a:t>
             </a:r>
@@ -11435,8 +11435,8 @@
                   <a:srgbClr val="76B900"/>
                 </a:solidFill>
                 <a:latin typeface="Helvetica Neue"/>
-                <a:ea typeface="PingFang SC"/>
-                <a:cs typeface="PingFang SC"/>
+                <a:ea typeface="Hiragino Sans GB"/>
+                <a:cs typeface="Hiragino Sans GB"/>
               </a:rPr>
               <a:t>我们的故事</a:t>
             </a:r>
@@ -11482,8 +11482,8 @@
                   <a:srgbClr val="FFFFFF"/>
                 </a:solidFill>
                 <a:latin typeface="Helvetica Neue"/>
-                <a:ea typeface="PingFang SC"/>
-                <a:cs typeface="PingFang SC"/>
+                <a:ea typeface="Hiragino Sans GB"/>
+                <a:cs typeface="Hiragino Sans GB"/>
               </a:rPr>
               <a:t>从一颗图形芯片，到 AI 的引擎</a:t>
             </a:r>
@@ -11665,8 +11665,8 @@
                   <a:srgbClr val="FFFFFF"/>
                 </a:solidFill>
                 <a:latin typeface="Helvetica Neue"/>
-                <a:ea typeface="PingFang SC"/>
-                <a:cs typeface="PingFang SC"/>
+                <a:ea typeface="Hiragino Sans GB"/>
+                <a:cs typeface="Hiragino Sans GB"/>
               </a:rPr>
               <a:t>1993</a:t>
             </a:r>
@@ -11712,8 +11712,8 @@
                   <a:srgbClr val="C8CDD4"/>
                 </a:solidFill>
                 <a:latin typeface="Helvetica Neue"/>
-                <a:ea typeface="PingFang SC"/>
-                <a:cs typeface="PingFang SC"/>
+                <a:ea typeface="Hiragino Sans GB"/>
+                <a:cs typeface="Hiragino Sans GB"/>
               </a:rPr>
               <a:t>公司创立</a:t>
             </a:r>
@@ -11807,8 +11807,8 @@
                   <a:srgbClr val="FFFFFF"/>
                 </a:solidFill>
                 <a:latin typeface="Helvetica Neue"/>
-                <a:ea typeface="PingFang SC"/>
-                <a:cs typeface="PingFang SC"/>
+                <a:ea typeface="Hiragino Sans GB"/>
+                <a:cs typeface="Hiragino Sans GB"/>
               </a:rPr>
               <a:t>1999</a:t>
             </a:r>
@@ -11854,8 +11854,8 @@
                   <a:srgbClr val="C8CDD4"/>
                 </a:solidFill>
                 <a:latin typeface="Helvetica Neue"/>
-                <a:ea typeface="PingFang SC"/>
-                <a:cs typeface="PingFang SC"/>
+                <a:ea typeface="Hiragino Sans GB"/>
+                <a:cs typeface="Hiragino Sans GB"/>
               </a:rPr>
               <a:t>发明 GPU</a:t>
             </a:r>
@@ -11949,8 +11949,8 @@
                   <a:srgbClr val="FFFFFF"/>
                 </a:solidFill>
                 <a:latin typeface="Helvetica Neue"/>
-                <a:ea typeface="PingFang SC"/>
-                <a:cs typeface="PingFang SC"/>
+                <a:ea typeface="Hiragino Sans GB"/>
+                <a:cs typeface="Hiragino Sans GB"/>
               </a:rPr>
               <a:t>2006</a:t>
             </a:r>
@@ -11996,8 +11996,8 @@
                   <a:srgbClr val="C8CDD4"/>
                 </a:solidFill>
                 <a:latin typeface="Helvetica Neue"/>
-                <a:ea typeface="PingFang SC"/>
-                <a:cs typeface="PingFang SC"/>
+                <a:ea typeface="Hiragino Sans GB"/>
+                <a:cs typeface="Hiragino Sans GB"/>
               </a:rPr>
               <a:t>CUDA 软件</a:t>
             </a:r>
@@ -12091,8 +12091,8 @@
                   <a:srgbClr val="FFFFFF"/>
                 </a:solidFill>
                 <a:latin typeface="Helvetica Neue"/>
-                <a:ea typeface="PingFang SC"/>
-                <a:cs typeface="PingFang SC"/>
+                <a:ea typeface="Hiragino Sans GB"/>
+                <a:cs typeface="Hiragino Sans GB"/>
               </a:rPr>
               <a:t>2012</a:t>
             </a:r>
@@ -12138,8 +12138,8 @@
                   <a:srgbClr val="C8CDD4"/>
                 </a:solidFill>
                 <a:latin typeface="Helvetica Neue"/>
-                <a:ea typeface="PingFang SC"/>
-                <a:cs typeface="PingFang SC"/>
+                <a:ea typeface="Hiragino Sans GB"/>
+                <a:cs typeface="Hiragino Sans GB"/>
               </a:rPr>
               <a:t>深度学习时代</a:t>
             </a:r>
@@ -12233,8 +12233,8 @@
                   <a:srgbClr val="76B900"/>
                 </a:solidFill>
                 <a:latin typeface="Helvetica Neue"/>
-                <a:ea typeface="PingFang SC"/>
-                <a:cs typeface="PingFang SC"/>
+                <a:ea typeface="Hiragino Sans GB"/>
+                <a:cs typeface="Hiragino Sans GB"/>
               </a:rPr>
               <a:t>2024–26</a:t>
             </a:r>
@@ -12280,8 +12280,8 @@
                   <a:srgbClr val="C8CDD4"/>
                 </a:solidFill>
                 <a:latin typeface="Helvetica Neue"/>
-                <a:ea typeface="PingFang SC"/>
-                <a:cs typeface="PingFang SC"/>
+                <a:ea typeface="Hiragino Sans GB"/>
+                <a:cs typeface="Hiragino Sans GB"/>
               </a:rPr>
               <a:t>AI 工厂</a:t>
             </a:r>
@@ -12327,8 +12327,8 @@
                   <a:srgbClr val="9AA3AE"/>
                 </a:solidFill>
                 <a:latin typeface="Helvetica Neue"/>
-                <a:ea typeface="PingFang SC"/>
-                <a:cs typeface="PingFang SC"/>
+                <a:ea typeface="Hiragino Sans GB"/>
+                <a:cs typeface="Hiragino Sans GB"/>
               </a:rPr>
               <a:t>三项发明，GPU、CUDA 和机架级 AI 系统，把 PC 图形变成了现代 AI 的引擎。</a:t>
             </a:r>
@@ -12398,8 +12398,8 @@
                   <a:srgbClr val="9AA3AE"/>
                 </a:solidFill>
                 <a:latin typeface="Helvetica Neue"/>
-                <a:ea typeface="PingFang SC"/>
-                <a:cs typeface="PingFang SC"/>
+                <a:ea typeface="Hiragino Sans GB"/>
+                <a:cs typeface="Hiragino Sans GB"/>
               </a:rPr>
               <a:t>03 / 16</a:t>
             </a:r>
@@ -12544,8 +12544,8 @@
                   <a:srgbClr val="76B900"/>
                 </a:solidFill>
                 <a:latin typeface="Helvetica Neue"/>
-                <a:ea typeface="PingFang SC"/>
-                <a:cs typeface="PingFang SC"/>
+                <a:ea typeface="Hiragino Sans GB"/>
+                <a:cs typeface="Hiragino Sans GB"/>
               </a:rPr>
               <a:t>我们造什么</a:t>
             </a:r>
@@ -12591,8 +12591,8 @@
                   <a:srgbClr val="FFFFFF"/>
                 </a:solidFill>
                 <a:latin typeface="Helvetica Neue"/>
-                <a:ea typeface="PingFang SC"/>
-                <a:cs typeface="PingFang SC"/>
+                <a:ea typeface="Hiragino Sans GB"/>
+                <a:cs typeface="Hiragino Sans GB"/>
               </a:rPr>
               <a:t>一个平台，多种引擎</a:t>
             </a:r>
@@ -12801,8 +12801,8 @@
                   <a:srgbClr val="FFFFFF"/>
                 </a:solidFill>
                 <a:latin typeface="Helvetica Neue"/>
-                <a:ea typeface="PingFang SC"/>
-                <a:cs typeface="PingFang SC"/>
+                <a:ea typeface="Hiragino Sans GB"/>
+                <a:cs typeface="Hiragino Sans GB"/>
               </a:rPr>
               <a:t>AI 与数据中心</a:t>
             </a:r>
@@ -12848,8 +12848,8 @@
                   <a:srgbClr val="9AA3AE"/>
                 </a:solidFill>
                 <a:latin typeface="Helvetica Neue"/>
-                <a:ea typeface="PingFang SC"/>
-                <a:cs typeface="PingFang SC"/>
+                <a:ea typeface="Hiragino Sans GB"/>
+                <a:cs typeface="Hiragino Sans GB"/>
               </a:rPr>
               <a:t>运行全世界 AI 的全栈 GPU 与系统。</a:t>
             </a:r>
@@ -13014,8 +13014,8 @@
                   <a:srgbClr val="FFFFFF"/>
                 </a:solidFill>
                 <a:latin typeface="Helvetica Neue"/>
-                <a:ea typeface="PingFang SC"/>
-                <a:cs typeface="PingFang SC"/>
+                <a:ea typeface="Hiragino Sans GB"/>
+                <a:cs typeface="Hiragino Sans GB"/>
               </a:rPr>
               <a:t>GeForce RTX 游戏</a:t>
             </a:r>
@@ -13061,8 +13061,8 @@
                   <a:srgbClr val="9AA3AE"/>
                 </a:solidFill>
                 <a:latin typeface="Helvetica Neue"/>
-                <a:ea typeface="PingFang SC"/>
-                <a:cs typeface="PingFang SC"/>
+                <a:ea typeface="Hiragino Sans GB"/>
+                <a:cs typeface="Hiragino Sans GB"/>
               </a:rPr>
               <a:t>为游戏带来实时光线追踪与 AI 渲染。</a:t>
             </a:r>
@@ -13227,8 +13227,8 @@
                   <a:srgbClr val="FFFFFF"/>
                 </a:solidFill>
                 <a:latin typeface="Helvetica Neue"/>
-                <a:ea typeface="PingFang SC"/>
-                <a:cs typeface="PingFang SC"/>
+                <a:ea typeface="Hiragino Sans GB"/>
+                <a:cs typeface="Hiragino Sans GB"/>
               </a:rPr>
               <a:t>Omniverse 与专业可视化</a:t>
             </a:r>
@@ -13274,8 +13274,8 @@
                   <a:srgbClr val="9AA3AE"/>
                 </a:solidFill>
                 <a:latin typeface="Helvetica Neue"/>
-                <a:ea typeface="PingFang SC"/>
-                <a:cs typeface="PingFang SC"/>
+                <a:ea typeface="Hiragino Sans GB"/>
+                <a:cs typeface="Hiragino Sans GB"/>
               </a:rPr>
               <a:t>物理精确的 3D 仿真与数字孪生。</a:t>
             </a:r>
@@ -13440,8 +13440,8 @@
                   <a:srgbClr val="FFFFFF"/>
                 </a:solidFill>
                 <a:latin typeface="Helvetica Neue"/>
-                <a:ea typeface="PingFang SC"/>
-                <a:cs typeface="PingFang SC"/>
+                <a:ea typeface="Hiragino Sans GB"/>
+                <a:cs typeface="Hiragino Sans GB"/>
               </a:rPr>
               <a:t>机器人与汽车</a:t>
             </a:r>
@@ -13487,8 +13487,8 @@
                   <a:srgbClr val="9AA3AE"/>
                 </a:solidFill>
                 <a:latin typeface="Helvetica Neue"/>
-                <a:ea typeface="PingFang SC"/>
-                <a:cs typeface="PingFang SC"/>
+                <a:ea typeface="Hiragino Sans GB"/>
+                <a:cs typeface="Hiragino Sans GB"/>
               </a:rPr>
               <a:t>为车辆、机器人与边缘设备提供车载 AI。</a:t>
             </a:r>
@@ -13558,8 +13558,8 @@
                   <a:srgbClr val="9AA3AE"/>
                 </a:solidFill>
                 <a:latin typeface="Helvetica Neue"/>
-                <a:ea typeface="PingFang SC"/>
-                <a:cs typeface="PingFang SC"/>
+                <a:ea typeface="Hiragino Sans GB"/>
+                <a:cs typeface="Hiragino Sans GB"/>
               </a:rPr>
               <a:t>04 / 16</a:t>
             </a:r>
@@ -13704,8 +13704,8 @@
                   <a:srgbClr val="76B900"/>
                 </a:solidFill>
                 <a:latin typeface="Helvetica Neue"/>
-                <a:ea typeface="PingFang SC"/>
-                <a:cs typeface="PingFang SC"/>
+                <a:ea typeface="Hiragino Sans GB"/>
+                <a:cs typeface="Hiragino Sans GB"/>
               </a:rPr>
               <a:t>用数字说话</a:t>
             </a:r>
@@ -13751,8 +13751,8 @@
                   <a:srgbClr val="FFFFFF"/>
                 </a:solidFill>
                 <a:latin typeface="Helvetica Neue"/>
-                <a:ea typeface="PingFang SC"/>
-                <a:cs typeface="PingFang SC"/>
+                <a:ea typeface="Hiragino Sans GB"/>
+                <a:cs typeface="Hiragino Sans GB"/>
               </a:rPr>
               <a:t>规模与地位</a:t>
             </a:r>
@@ -13936,8 +13936,8 @@
                   <a:srgbClr val="76B900"/>
                 </a:solidFill>
                 <a:latin typeface="Helvetica Neue"/>
-                <a:ea typeface="PingFang SC"/>
-                <a:cs typeface="PingFang SC"/>
+                <a:ea typeface="Hiragino Sans GB"/>
+                <a:cs typeface="Hiragino Sans GB"/>
               </a:rPr>
               <a:t>$215.9B</a:t>
             </a:r>
@@ -13983,8 +13983,8 @@
                   <a:srgbClr val="FFFFFF"/>
                 </a:solidFill>
                 <a:latin typeface="Helvetica Neue"/>
-                <a:ea typeface="PingFang SC"/>
-                <a:cs typeface="PingFang SC"/>
+                <a:ea typeface="Hiragino Sans GB"/>
+                <a:cs typeface="Hiragino Sans GB"/>
               </a:rPr>
               <a:t>2026 财年营收</a:t>
             </a:r>
@@ -14030,8 +14030,8 @@
                   <a:srgbClr val="9AA3AE"/>
                 </a:solidFill>
                 <a:latin typeface="Helvetica Neue"/>
-                <a:ea typeface="PingFang SC"/>
-                <a:cs typeface="PingFang SC"/>
+                <a:ea typeface="Hiragino Sans GB"/>
+                <a:cs typeface="Hiragino Sans GB"/>
               </a:rPr>
               <a:t>同比 +65%</a:t>
             </a:r>
@@ -14156,7 +14156,7 @@
           <a:p>
             <a:r>
               <a:rPr sz="2400">
-                <a:ea typeface="PingFang SC"/>
+                <a:ea typeface="Hiragino Sans GB"/>
               </a:rPr>
               <a:t>约</a:t>
             </a:r>
@@ -14208,8 +14208,8 @@
                   <a:srgbClr val="FFFFFF"/>
                 </a:solidFill>
                 <a:latin typeface="Helvetica Neue"/>
-                <a:ea typeface="PingFang SC"/>
-                <a:cs typeface="PingFang SC"/>
+                <a:ea typeface="Hiragino Sans GB"/>
+                <a:cs typeface="Hiragino Sans GB"/>
               </a:rPr>
               <a:t>市值</a:t>
             </a:r>
@@ -14255,8 +14255,8 @@
                   <a:srgbClr val="9AA3AE"/>
                 </a:solidFill>
                 <a:latin typeface="Helvetica Neue"/>
-                <a:ea typeface="PingFang SC"/>
-                <a:cs typeface="PingFang SC"/>
+                <a:ea typeface="Hiragino Sans GB"/>
+                <a:cs typeface="Hiragino Sans GB"/>
               </a:rPr>
               <a:t>全球第一</a:t>
             </a:r>
@@ -14396,8 +14396,8 @@
                   <a:srgbClr val="76B900"/>
                 </a:solidFill>
                 <a:latin typeface="Helvetica Neue"/>
-                <a:ea typeface="PingFang SC"/>
-                <a:cs typeface="PingFang SC"/>
+                <a:ea typeface="Hiragino Sans GB"/>
+                <a:cs typeface="Hiragino Sans GB"/>
               </a:rPr>
               <a:t>74.9%</a:t>
             </a:r>
@@ -14443,8 +14443,8 @@
                   <a:srgbClr val="FFFFFF"/>
                 </a:solidFill>
                 <a:latin typeface="Helvetica Neue"/>
-                <a:ea typeface="PingFang SC"/>
-                <a:cs typeface="PingFang SC"/>
+                <a:ea typeface="Hiragino Sans GB"/>
+                <a:cs typeface="Hiragino Sans GB"/>
               </a:rPr>
               <a:t>毛利率</a:t>
             </a:r>
@@ -14490,8 +14490,8 @@
                   <a:srgbClr val="9AA3AE"/>
                 </a:solidFill>
                 <a:latin typeface="Helvetica Neue"/>
-                <a:ea typeface="PingFang SC"/>
-                <a:cs typeface="PingFang SC"/>
+                <a:ea typeface="Hiragino Sans GB"/>
+                <a:cs typeface="Hiragino Sans GB"/>
               </a:rPr>
               <a:t>2027 财年一季度，GAAP</a:t>
             </a:r>
@@ -14616,7 +14616,7 @@
           <a:p>
             <a:r>
               <a:rPr sz="2400">
-                <a:ea typeface="PingFang SC"/>
+                <a:ea typeface="Hiragino Sans GB"/>
               </a:rPr>
               <a:t>约</a:t>
             </a:r>
@@ -14624,7 +14624,7 @@
           <a:p>
             <a:r>
               <a:rPr sz="2400">
-                <a:ea typeface="PingFang SC"/>
+                <a:ea typeface="Hiragino Sans GB"/>
               </a:rPr>
               <a:t>600 万</a:t>
             </a:r>
@@ -14670,8 +14670,8 @@
                   <a:srgbClr val="FFFFFF"/>
                 </a:solidFill>
                 <a:latin typeface="Helvetica Neue"/>
-                <a:ea typeface="PingFang SC"/>
-                <a:cs typeface="PingFang SC"/>
+                <a:ea typeface="Hiragino Sans GB"/>
+                <a:cs typeface="Hiragino Sans GB"/>
               </a:rPr>
               <a:t>CUDA 开发者</a:t>
             </a:r>
@@ -14717,8 +14717,8 @@
                   <a:srgbClr val="9AA3AE"/>
                 </a:solidFill>
                 <a:latin typeface="Helvetica Neue"/>
-                <a:ea typeface="PingFang SC"/>
-                <a:cs typeface="PingFang SC"/>
+                <a:ea typeface="Hiragino Sans GB"/>
+                <a:cs typeface="Hiragino Sans GB"/>
               </a:rPr>
               <a:t>200+ 个国家</a:t>
             </a:r>
@@ -14764,8 +14764,8 @@
                   <a:srgbClr val="9AA3AE"/>
                 </a:solidFill>
                 <a:latin typeface="Helvetica Neue"/>
-                <a:ea typeface="PingFang SC"/>
-                <a:cs typeface="PingFang SC"/>
+                <a:ea typeface="Hiragino Sans GB"/>
+                <a:cs typeface="Hiragino Sans GB"/>
               </a:rPr>
               <a:t>营收为 2026 财年（截至 2026 年 1 月 25 日）；毛利率为 2027 财年一季度（2026 年 4 月 26 日）；开发者数据截至 GTC 2025；市值约为 2026 年 6 月（近似值，盘中波动）。</a:t>
             </a:r>
@@ -14835,8 +14835,8 @@
                   <a:srgbClr val="9AA3AE"/>
                 </a:solidFill>
                 <a:latin typeface="Helvetica Neue"/>
-                <a:ea typeface="PingFang SC"/>
-                <a:cs typeface="PingFang SC"/>
+                <a:ea typeface="Hiragino Sans GB"/>
+                <a:cs typeface="Hiragino Sans GB"/>
               </a:rPr>
               <a:t>05 / 16</a:t>
             </a:r>
@@ -14981,8 +14981,8 @@
                   <a:srgbClr val="76B900"/>
                 </a:solidFill>
                 <a:latin typeface="Helvetica Neue"/>
-                <a:ea typeface="PingFang SC"/>
-                <a:cs typeface="PingFang SC"/>
+                <a:ea typeface="Hiragino Sans GB"/>
+                <a:cs typeface="Hiragino Sans GB"/>
               </a:rPr>
               <a:t>数据中心 · 核心</a:t>
             </a:r>
@@ -15028,8 +15028,8 @@
                   <a:srgbClr val="FFFFFF"/>
                 </a:solidFill>
                 <a:latin typeface="Helvetica Neue"/>
-                <a:ea typeface="PingFang SC"/>
-                <a:cs typeface="PingFang SC"/>
+                <a:ea typeface="Hiragino Sans GB"/>
+                <a:cs typeface="Hiragino Sans GB"/>
               </a:rPr>
               <a:t>NVIDIA 造的是 AI 工厂，不只是芯片</a:t>
             </a:r>
@@ -15213,8 +15213,8 @@
                   <a:srgbClr val="C8CDD4"/>
                 </a:solidFill>
                 <a:latin typeface="Helvetica Neue"/>
-                <a:ea typeface="PingFang SC"/>
-                <a:cs typeface="PingFang SC"/>
+                <a:ea typeface="Hiragino Sans GB"/>
+                <a:cs typeface="Hiragino Sans GB"/>
               </a:rPr>
               <a:t>Blackwell GPU</a:t>
             </a:r>
@@ -15354,8 +15354,8 @@
                   <a:srgbClr val="C8CDD4"/>
                 </a:solidFill>
                 <a:latin typeface="Helvetica Neue"/>
-                <a:ea typeface="PingFang SC"/>
-                <a:cs typeface="PingFang SC"/>
+                <a:ea typeface="Hiragino Sans GB"/>
+                <a:cs typeface="Hiragino Sans GB"/>
               </a:rPr>
               <a:t>Grace / Vera CPU</a:t>
             </a:r>
@@ -15495,8 +15495,8 @@
                   <a:srgbClr val="C8CDD4"/>
                 </a:solidFill>
                 <a:latin typeface="Helvetica Neue"/>
-                <a:ea typeface="PingFang SC"/>
-                <a:cs typeface="PingFang SC"/>
+                <a:ea typeface="Hiragino Sans GB"/>
+                <a:cs typeface="Hiragino Sans GB"/>
               </a:rPr>
               <a:t>NVLink 与 NVSwitch 互联</a:t>
             </a:r>
@@ -15636,8 +15636,8 @@
                   <a:srgbClr val="C8CDD4"/>
                 </a:solidFill>
                 <a:latin typeface="Helvetica Neue"/>
-                <a:ea typeface="PingFang SC"/>
-                <a:cs typeface="PingFang SC"/>
+                <a:ea typeface="Hiragino Sans GB"/>
+                <a:cs typeface="Hiragino Sans GB"/>
               </a:rPr>
               <a:t>InfiniBand / Spectrum-X 网络</a:t>
             </a:r>
@@ -15777,8 +15777,8 @@
                   <a:srgbClr val="C8CDD4"/>
                 </a:solidFill>
                 <a:latin typeface="Helvetica Neue"/>
-                <a:ea typeface="PingFang SC"/>
-                <a:cs typeface="PingFang SC"/>
+                <a:ea typeface="Hiragino Sans GB"/>
+                <a:cs typeface="Hiragino Sans GB"/>
               </a:rPr>
               <a:t>CUDA 与 AI 软件</a:t>
             </a:r>
@@ -15980,8 +15980,8 @@
                   <a:srgbClr val="FFFFFF"/>
                 </a:solidFill>
                 <a:latin typeface="Helvetica Neue"/>
-                <a:ea typeface="PingFang SC"/>
-                <a:cs typeface="PingFang SC"/>
+                <a:ea typeface="Hiragino Sans GB"/>
+                <a:cs typeface="Hiragino Sans GB"/>
               </a:rPr>
               <a:t>一座机架级 AI 工厂</a:t>
             </a:r>
@@ -16027,8 +16027,8 @@
                   <a:srgbClr val="C8CDD4"/>
                 </a:solidFill>
                 <a:latin typeface="Helvetica Neue"/>
-                <a:ea typeface="PingFang SC"/>
-                <a:cs typeface="PingFang SC"/>
+                <a:ea typeface="Hiragino Sans GB"/>
+                <a:cs typeface="Hiragino Sans GB"/>
               </a:rPr>
               <a:t>GB300 NVL72 把 72 颗 GPU 融合成一台巨型加速器，作为开箱即用的完整系统交付。</a:t>
             </a:r>
@@ -16074,8 +16074,8 @@
                   <a:srgbClr val="9AA3AE"/>
                 </a:solidFill>
                 <a:latin typeface="Helvetica Neue"/>
-                <a:ea typeface="PingFang SC"/>
-                <a:cs typeface="PingFang SC"/>
+                <a:ea typeface="Hiragino Sans GB"/>
+                <a:cs typeface="Hiragino Sans GB"/>
               </a:rPr>
               <a:t>数据中心是引擎：上季度 $75.2B，约占营收 92%（2027 财年一季度，截至 2026 年 4 月 26 日）。</a:t>
             </a:r>
@@ -16145,8 +16145,8 @@
                   <a:srgbClr val="9AA3AE"/>
                 </a:solidFill>
                 <a:latin typeface="Helvetica Neue"/>
-                <a:ea typeface="PingFang SC"/>
-                <a:cs typeface="PingFang SC"/>
+                <a:ea typeface="Hiragino Sans GB"/>
+                <a:cs typeface="Hiragino Sans GB"/>
               </a:rPr>
               <a:t>06 / 16</a:t>
             </a:r>
@@ -16291,8 +16291,8 @@
                   <a:srgbClr val="76B900"/>
                 </a:solidFill>
                 <a:latin typeface="Helvetica Neue"/>
-                <a:ea typeface="PingFang SC"/>
-                <a:cs typeface="PingFang SC"/>
+                <a:ea typeface="Hiragino Sans GB"/>
+                <a:cs typeface="Hiragino Sans GB"/>
               </a:rPr>
               <a:t>年度节奏</a:t>
             </a:r>
@@ -16338,8 +16338,8 @@
                   <a:srgbClr val="FFFFFF"/>
                 </a:solidFill>
                 <a:latin typeface="Helvetica Neue"/>
-                <a:ea typeface="PingFang SC"/>
-                <a:cs typeface="PingFang SC"/>
+                <a:ea typeface="Hiragino Sans GB"/>
+                <a:cs typeface="Hiragino Sans GB"/>
               </a:rPr>
               <a:t>当下是 Blackwell Ultra，下一站 Vera Rubin</a:t>
             </a:r>
@@ -16570,8 +16570,8 @@
                   <a:srgbClr val="0A0B0D"/>
                 </a:solidFill>
                 <a:latin typeface="Helvetica Neue"/>
-                <a:ea typeface="PingFang SC"/>
-                <a:cs typeface="PingFang SC"/>
+                <a:ea typeface="Hiragino Sans GB"/>
+                <a:cs typeface="Hiragino Sans GB"/>
               </a:rPr>
               <a:t>现在</a:t>
             </a:r>
@@ -16617,8 +16617,8 @@
                   <a:srgbClr val="FFFFFF"/>
                 </a:solidFill>
                 <a:latin typeface="Helvetica Neue"/>
-                <a:ea typeface="PingFang SC"/>
-                <a:cs typeface="PingFang SC"/>
+                <a:ea typeface="Hiragino Sans GB"/>
+                <a:cs typeface="Hiragino Sans GB"/>
               </a:rPr>
               <a:t>Blackwell Ultra</a:t>
             </a:r>
@@ -16664,8 +16664,8 @@
                   <a:srgbClr val="C8CDD4"/>
                 </a:solidFill>
                 <a:latin typeface="Helvetica Neue"/>
-                <a:ea typeface="PingFang SC"/>
-                <a:cs typeface="PingFang SC"/>
+                <a:ea typeface="Hiragino Sans GB"/>
+                <a:cs typeface="Hiragino Sans GB"/>
               </a:rPr>
               <a:t>GB300 / GB300 NVL72，已在规模化出货。</a:t>
             </a:r>
@@ -16852,8 +16852,8 @@
                   <a:srgbClr val="0A0B0D"/>
                 </a:solidFill>
                 <a:latin typeface="Helvetica Neue"/>
-                <a:ea typeface="PingFang SC"/>
-                <a:cs typeface="PingFang SC"/>
+                <a:ea typeface="Hiragino Sans GB"/>
+                <a:cs typeface="Hiragino Sans GB"/>
               </a:rPr>
               <a:t>下一站</a:t>
             </a:r>
@@ -16899,8 +16899,8 @@
                   <a:srgbClr val="FFFFFF"/>
                 </a:solidFill>
                 <a:latin typeface="Helvetica Neue"/>
-                <a:ea typeface="PingFang SC"/>
-                <a:cs typeface="PingFang SC"/>
+                <a:ea typeface="Hiragino Sans GB"/>
+                <a:cs typeface="Hiragino Sans GB"/>
               </a:rPr>
               <a:t>Vera Rubin</a:t>
             </a:r>
@@ -16946,8 +16946,8 @@
                   <a:srgbClr val="C8CDD4"/>
                 </a:solidFill>
                 <a:latin typeface="Helvetica Neue"/>
-                <a:ea typeface="PingFang SC"/>
-                <a:cs typeface="PingFang SC"/>
+                <a:ea typeface="Hiragino Sans GB"/>
+                <a:cs typeface="Hiragino Sans GB"/>
               </a:rPr>
               <a:t>新一代平台，2026 年秋季全面量产。</a:t>
             </a:r>
@@ -17030,8 +17030,8 @@
                   <a:srgbClr val="9AA3AE"/>
                 </a:solidFill>
                 <a:latin typeface="Helvetica Neue"/>
-                <a:ea typeface="PingFang SC"/>
-                <a:cs typeface="PingFang SC"/>
+                <a:ea typeface="Hiragino Sans GB"/>
+                <a:cs typeface="Hiragino Sans GB"/>
               </a:rPr>
               <a:t>截至 2026 年，Blackwell 加 Rubin 的累计订单已超过 $500B（2025 年 10 月 29 日披露）。</a:t>
             </a:r>
@@ -17101,8 +17101,8 @@
                   <a:srgbClr val="9AA3AE"/>
                 </a:solidFill>
                 <a:latin typeface="Helvetica Neue"/>
-                <a:ea typeface="PingFang SC"/>
-                <a:cs typeface="PingFang SC"/>
+                <a:ea typeface="Hiragino Sans GB"/>
+                <a:cs typeface="Hiragino Sans GB"/>
               </a:rPr>
               <a:t>07 / 16</a:t>
             </a:r>
@@ -17247,8 +17247,8 @@
                   <a:srgbClr val="76B900"/>
                 </a:solidFill>
                 <a:latin typeface="Helvetica Neue"/>
-                <a:ea typeface="PingFang SC"/>
-                <a:cs typeface="PingFang SC"/>
+                <a:ea typeface="Hiragino Sans GB"/>
+                <a:cs typeface="Hiragino Sans GB"/>
               </a:rPr>
               <a:t>谁在用</a:t>
             </a:r>
@@ -17294,8 +17294,8 @@
                   <a:srgbClr val="FFFFFF"/>
                 </a:solidFill>
                 <a:latin typeface="Helvetica Neue"/>
-                <a:ea typeface="PingFang SC"/>
-                <a:cs typeface="PingFang SC"/>
+                <a:ea typeface="Hiragino Sans GB"/>
+                <a:cs typeface="Hiragino Sans GB"/>
               </a:rPr>
               <a:t>谁跑在 NVIDIA 上</a:t>
             </a:r>
@@ -17504,8 +17504,8 @@
                   <a:srgbClr val="FFFFFF"/>
                 </a:solidFill>
                 <a:latin typeface="Helvetica Neue"/>
-                <a:ea typeface="PingFang SC"/>
-                <a:cs typeface="PingFang SC"/>
+                <a:ea typeface="Hiragino Sans GB"/>
+                <a:cs typeface="Hiragino Sans GB"/>
               </a:rPr>
               <a:t>云与 AI 服务商</a:t>
             </a:r>
@@ -17599,8 +17599,8 @@
                   <a:srgbClr val="C8CDD4"/>
                 </a:solidFill>
                 <a:latin typeface="Helvetica Neue"/>
-                <a:ea typeface="PingFang SC"/>
-                <a:cs typeface="PingFang SC"/>
+                <a:ea typeface="Hiragino Sans GB"/>
+                <a:cs typeface="Hiragino Sans GB"/>
               </a:rPr>
               <a:t>CoreWeave</a:t>
             </a:r>
@@ -17694,8 +17694,8 @@
                   <a:srgbClr val="C8CDD4"/>
                 </a:solidFill>
                 <a:latin typeface="Helvetica Neue"/>
-                <a:ea typeface="PingFang SC"/>
-                <a:cs typeface="PingFang SC"/>
+                <a:ea typeface="Hiragino Sans GB"/>
+                <a:cs typeface="Hiragino Sans GB"/>
               </a:rPr>
               <a:t>Oracle Cloud</a:t>
             </a:r>
@@ -17789,8 +17789,8 @@
                   <a:srgbClr val="C8CDD4"/>
                 </a:solidFill>
                 <a:latin typeface="Helvetica Neue"/>
-                <a:ea typeface="PingFang SC"/>
-                <a:cs typeface="PingFang SC"/>
+                <a:ea typeface="Hiragino Sans GB"/>
+                <a:cs typeface="Hiragino Sans GB"/>
               </a:rPr>
               <a:t>Microsoft Azure</a:t>
             </a:r>
@@ -17884,8 +17884,8 @@
                   <a:srgbClr val="C8CDD4"/>
                 </a:solidFill>
                 <a:latin typeface="Helvetica Neue"/>
-                <a:ea typeface="PingFang SC"/>
-                <a:cs typeface="PingFang SC"/>
+                <a:ea typeface="Hiragino Sans GB"/>
+                <a:cs typeface="Hiragino Sans GB"/>
               </a:rPr>
               <a:t>Lambda</a:t>
             </a:r>
@@ -18050,8 +18050,8 @@
                   <a:srgbClr val="FFFFFF"/>
                 </a:solidFill>
                 <a:latin typeface="Helvetica Neue"/>
-                <a:ea typeface="PingFang SC"/>
-                <a:cs typeface="PingFang SC"/>
+                <a:ea typeface="Hiragino Sans GB"/>
+                <a:cs typeface="Hiragino Sans GB"/>
               </a:rPr>
               <a:t>系统厂商</a:t>
             </a:r>
@@ -18145,8 +18145,8 @@
                   <a:srgbClr val="C8CDD4"/>
                 </a:solidFill>
                 <a:latin typeface="Helvetica Neue"/>
-                <a:ea typeface="PingFang SC"/>
-                <a:cs typeface="PingFang SC"/>
+                <a:ea typeface="Hiragino Sans GB"/>
+                <a:cs typeface="Hiragino Sans GB"/>
               </a:rPr>
               <a:t>Dell</a:t>
             </a:r>
@@ -18240,8 +18240,8 @@
                   <a:srgbClr val="C8CDD4"/>
                 </a:solidFill>
                 <a:latin typeface="Helvetica Neue"/>
-                <a:ea typeface="PingFang SC"/>
-                <a:cs typeface="PingFang SC"/>
+                <a:ea typeface="Hiragino Sans GB"/>
+                <a:cs typeface="Hiragino Sans GB"/>
               </a:rPr>
               <a:t>HPE</a:t>
             </a:r>
@@ -18335,8 +18335,8 @@
                   <a:srgbClr val="C8CDD4"/>
                 </a:solidFill>
                 <a:latin typeface="Helvetica Neue"/>
-                <a:ea typeface="PingFang SC"/>
-                <a:cs typeface="PingFang SC"/>
+                <a:ea typeface="Hiragino Sans GB"/>
+                <a:cs typeface="Hiragino Sans GB"/>
               </a:rPr>
               <a:t>Lenovo</a:t>
             </a:r>
@@ -18430,8 +18430,8 @@
                   <a:srgbClr val="C8CDD4"/>
                 </a:solidFill>
                 <a:latin typeface="Helvetica Neue"/>
-                <a:ea typeface="PingFang SC"/>
-                <a:cs typeface="PingFang SC"/>
+                <a:ea typeface="Hiragino Sans GB"/>
+                <a:cs typeface="Hiragino Sans GB"/>
               </a:rPr>
               <a:t>Supermicro</a:t>
             </a:r>
@@ -18596,8 +18596,8 @@
                   <a:srgbClr val="FFFFFF"/>
                 </a:solidFill>
                 <a:latin typeface="Helvetica Neue"/>
-                <a:ea typeface="PingFang SC"/>
-                <a:cs typeface="PingFang SC"/>
+                <a:ea typeface="Hiragino Sans GB"/>
+                <a:cs typeface="Hiragino Sans GB"/>
               </a:rPr>
               <a:t>主权 AI</a:t>
             </a:r>
@@ -18643,8 +18643,8 @@
                   <a:srgbClr val="76B900"/>
                 </a:solidFill>
                 <a:latin typeface="Helvetica Neue"/>
-                <a:ea typeface="PingFang SC"/>
-                <a:cs typeface="PingFang SC"/>
+                <a:ea typeface="Hiragino Sans GB"/>
+                <a:cs typeface="Hiragino Sans GB"/>
               </a:rPr>
               <a:t>约 40</a:t>
             </a:r>
@@ -18690,8 +18690,8 @@
                   <a:srgbClr val="C8CDD4"/>
                 </a:solidFill>
                 <a:latin typeface="Helvetica Neue"/>
-                <a:ea typeface="PingFang SC"/>
-                <a:cs typeface="PingFang SC"/>
+                <a:ea typeface="Hiragino Sans GB"/>
+                <a:cs typeface="Hiragino Sans GB"/>
               </a:rPr>
               <a:t>个国家正在 NVIDIA 上搭建本国的国家级 AI 基础设施。</a:t>
             </a:r>
@@ -18737,8 +18737,8 @@
                   <a:srgbClr val="9AA3AE"/>
                 </a:solidFill>
                 <a:latin typeface="Helvetica Neue"/>
-                <a:ea typeface="PingFang SC"/>
-                <a:cs typeface="PingFang SC"/>
+                <a:ea typeface="Hiragino Sans GB"/>
+                <a:cs typeface="Hiragino Sans GB"/>
               </a:rPr>
               <a:t>云 / OEM 合作伙伴，以及约 40 国的主权 AI 计数，截至 2025–26 年。</a:t>
             </a:r>
@@ -18808,8 +18808,8 @@
                   <a:srgbClr val="9AA3AE"/>
                 </a:solidFill>
                 <a:latin typeface="Helvetica Neue"/>
-                <a:ea typeface="PingFang SC"/>
-                <a:cs typeface="PingFang SC"/>
+                <a:ea typeface="Hiragino Sans GB"/>
+                <a:cs typeface="Hiragino Sans GB"/>
               </a:rPr>
               <a:t>08 / 16</a:t>
             </a:r>
@@ -18954,8 +18954,8 @@
                   <a:srgbClr val="76B900"/>
                 </a:solidFill>
                 <a:latin typeface="Helvetica Neue"/>
-                <a:ea typeface="PingFang SC"/>
-                <a:cs typeface="PingFang SC"/>
+                <a:ea typeface="Hiragino Sans GB"/>
+                <a:cs typeface="Hiragino Sans GB"/>
               </a:rPr>
               <a:t>护城河</a:t>
             </a:r>
@@ -19001,8 +19001,8 @@
                   <a:srgbClr val="FFFFFF"/>
                 </a:solidFill>
                 <a:latin typeface="Helvetica Neue"/>
-                <a:ea typeface="PingFang SC"/>
-                <a:cs typeface="PingFang SC"/>
+                <a:ea typeface="Hiragino Sans GB"/>
+                <a:cs typeface="Hiragino Sans GB"/>
               </a:rPr>
               <a:t>软件才是持久的优势</a:t>
             </a:r>
@@ -19077,7 +19077,7 @@
           <a:p>
             <a:r>
               <a:rPr sz="2400">
-                <a:ea typeface="PingFang SC"/>
+                <a:ea typeface="Hiragino Sans GB"/>
               </a:rPr>
               <a:t>约</a:t>
             </a:r>
@@ -19085,7 +19085,7 @@
           <a:p>
             <a:r>
               <a:rPr sz="2400">
-                <a:ea typeface="PingFang SC"/>
+                <a:ea typeface="Hiragino Sans GB"/>
               </a:rPr>
               <a:t>600 万</a:t>
             </a:r>
@@ -19131,8 +19131,8 @@
                   <a:srgbClr val="FFFFFF"/>
                 </a:solidFill>
                 <a:latin typeface="Helvetica Neue"/>
-                <a:ea typeface="PingFang SC"/>
-                <a:cs typeface="PingFang SC"/>
+                <a:ea typeface="Hiragino Sans GB"/>
+                <a:cs typeface="Hiragino Sans GB"/>
               </a:rPr>
               <a:t>全球开发者</a:t>
             </a:r>
@@ -19178,8 +19178,8 @@
                   <a:srgbClr val="9AA3AE"/>
                 </a:solidFill>
                 <a:latin typeface="Helvetica Neue"/>
-                <a:ea typeface="PingFang SC"/>
-                <a:cs typeface="PingFang SC"/>
+                <a:ea typeface="Hiragino Sans GB"/>
+                <a:cs typeface="Hiragino Sans GB"/>
               </a:rPr>
               <a:t>200+ 个国家 · 900+ 个 CUDA-X 库（截至 GTC 2025）。</a:t>
             </a:r>
@@ -19269,8 +19269,8 @@
                   <a:srgbClr val="C8CDD4"/>
                 </a:solidFill>
                 <a:latin typeface="Helvetica Neue"/>
-                <a:ea typeface="PingFang SC"/>
-                <a:cs typeface="PingFang SC"/>
+                <a:ea typeface="Hiragino Sans GB"/>
+                <a:cs typeface="Hiragino Sans GB"/>
               </a:rPr>
               <a:t>CUDA（始于 2006 年）让每一颗 NVIDIA GPU 都能即刻编程。</a:t>
             </a:r>
@@ -19360,8 +19360,8 @@
                   <a:srgbClr val="C8CDD4"/>
                 </a:solidFill>
                 <a:latin typeface="Helvetica Neue"/>
-                <a:ea typeface="PingFang SC"/>
-                <a:cs typeface="PingFang SC"/>
+                <a:ea typeface="Hiragino Sans GB"/>
+                <a:cs typeface="Hiragino Sans GB"/>
               </a:rPr>
               <a:t>AI Enterprise、NIM 微服务和开放的 Nemotron 模型，把它带进生产环境。</a:t>
             </a:r>
@@ -19451,8 +19451,8 @@
                   <a:srgbClr val="C8CDD4"/>
                 </a:solidFill>
                 <a:latin typeface="Helvetica Neue"/>
-                <a:ea typeface="PingFang SC"/>
-                <a:cs typeface="PingFang SC"/>
+                <a:ea typeface="Hiragino Sans GB"/>
+                <a:cs typeface="Hiragino Sans GB"/>
               </a:rPr>
               <a:t>生态越大，就越难离开这个平台。</a:t>
             </a:r>
@@ -19522,8 +19522,8 @@
                   <a:srgbClr val="9AA3AE"/>
                 </a:solidFill>
                 <a:latin typeface="Helvetica Neue"/>
-                <a:ea typeface="PingFang SC"/>
-                <a:cs typeface="PingFang SC"/>
+                <a:ea typeface="Hiragino Sans GB"/>
+                <a:cs typeface="Hiragino Sans GB"/>
               </a:rPr>
               <a:t>09 / 16</a:t>
             </a:r>

</xml_diff>

<commit_message>
Template QA round 2: fix invisible dark-on-dark text (uncolored runs defaulting to black)
- mj zh+en slide 11: card body text now light paper on dark cards
- nvidia zh slides 5/9: hero numerals (~$4.7T, ~6M) now NVIDIA green like siblings
- nl zh slides 3/4: card headers white bold, stray bullet lead navy bold (matches en ground truth)
All 16 decks re-linted clean; full visual contact-sheet pass done on every deck.

Co-Authored-By: Claude Fable 5 <noreply@anthropic.com>
</commit_message>
<xml_diff>
--- a/templates/decks/zh/nvidia-overview/template.pptx
+++ b/templates/decks/zh/nvidia-overview/template.pptx
@@ -14156,6 +14156,9 @@
           <a:p>
             <a:r>
               <a:rPr sz="2400">
+                <a:solidFill>
+                  <a:srgbClr val="76B900"/>
+                </a:solidFill>
                 <a:ea typeface="Hiragino Sans GB"/>
               </a:rPr>
               <a:t>约</a:t>
@@ -14163,7 +14166,11 @@
           </a:p>
           <a:p>
             <a:r>
-              <a:rPr sz="2400"/>
+              <a:rPr sz="2400">
+                <a:solidFill>
+                  <a:srgbClr val="76B900"/>
+                </a:solidFill>
+              </a:rPr>
               <a:t>$4.7T</a:t>
             </a:r>
           </a:p>
@@ -14616,6 +14623,9 @@
           <a:p>
             <a:r>
               <a:rPr sz="2400">
+                <a:solidFill>
+                  <a:srgbClr val="76B900"/>
+                </a:solidFill>
                 <a:ea typeface="Hiragino Sans GB"/>
               </a:rPr>
               <a:t>约</a:t>
@@ -14624,6 +14634,9 @@
           <a:p>
             <a:r>
               <a:rPr sz="2400">
+                <a:solidFill>
+                  <a:srgbClr val="76B900"/>
+                </a:solidFill>
                 <a:ea typeface="Hiragino Sans GB"/>
               </a:rPr>
               <a:t>600 万</a:t>
@@ -19077,6 +19090,9 @@
           <a:p>
             <a:r>
               <a:rPr sz="2400">
+                <a:solidFill>
+                  <a:srgbClr val="76B900"/>
+                </a:solidFill>
                 <a:ea typeface="Hiragino Sans GB"/>
               </a:rPr>
               <a:t>约</a:t>
@@ -19085,6 +19101,9 @@
           <a:p>
             <a:r>
               <a:rPr sz="2400">
+                <a:solidFill>
+                  <a:srgbClr val="76B900"/>
+                </a:solidFill>
                 <a:ea typeface="Hiragino Sans GB"/>
               </a:rPr>
               <a:t>600 万</a:t>

</xml_diff>